<commit_message>
Update Presentation and add Github_Repo_Link.pdf
</commit_message>
<xml_diff>
--- a/presentation/TapLend_Credit_Risk_Analysis.pptx
+++ b/presentation/TapLend_Credit_Risk_Analysis.pptx
@@ -306,24 +306,7 @@
           <a:bodyPr/>
           <a:lstStyle/>
           <a:p>
-            <a:r>
-              <a:t>SPEAKER NOTES (SLIDE 1):</a:t>
-            </a:r>
-          </a:p>
-          <a:p>
-            <a:r>
-              <a:t>Good morning/afternoon everyone. Today I'm presenting my credit risk analysis for TapLend India. </a:t>
-            </a:r>
-          </a:p>
-          <a:p>
-            <a:r>
-              <a:t>Our objective is to evaluate whether applicant characteristics captured at application time can reliably predict loan repayment outcomes—distinguishing Good loans from Bad loans.</a:t>
-            </a:r>
-          </a:p>
-          <a:p>
-            <a:r>
-              <a:t>Throughout this project, I audited the data architecture, verified identifier corrections, enforced fair-lending feature hygiene, built a leak-free machine learning workflow, and evaluated the economic trade-offs required before considering any automated underwriting. Let's begin.</a:t>
-            </a:r>
+            <a:endParaRPr dirty="0"/>
           </a:p>
         </p:txBody>
       </p:sp>
@@ -391,34 +374,7 @@
           <a:bodyPr/>
           <a:lstStyle/>
           <a:p>
-            <a:r>
-              <a:t>SPEAKER NOTES (SLIDE 10):</a:t>
-            </a:r>
-          </a:p>
-          <a:p>
-            <a:r>
-              <a:t>A key methodological correction in this revised analysis is eliminating test-set tuning. </a:t>
-            </a:r>
-          </a:p>
-          <a:p>
-            <a:r>
-              <a:t>We selected our optimal threshold strictly on training cross-validation data using Random Forest, finding T* = 0.30, and then evaluated it on the untouched holdout test set.</a:t>
-            </a:r>
-          </a:p>
-          <a:p>
-            <a:r>
-              <a:t>Under our illustrative cost assumptions ($500 default loss vs. $150 lost margin), setting T* = 0.30 reduces test loss from $14,150 to $9,650 (a $4,500 or 31.8% reduction).</a:t>
-            </a:r>
-          </a:p>
-          <a:p>
-            <a:r>
-              <a:t>However, look at the trade-off: false negatives drop to 1, but false positives jump to 61 out of 62 good borrowers! That means only 1 good applicant is approved (98.4% of good applicants are rejected), and loan origination volume collapses.</a:t>
-            </a:r>
-          </a:p>
-          <a:p>
-            <a:r>
-              <a:t>In a real lending business, underwriting teams cannot operate without loan volume constraints. Furthermore, with only 133 test cases, threshold optimization is highly sensitive to sample noise.</a:t>
-            </a:r>
+            <a:endParaRPr dirty="0"/>
           </a:p>
         </p:txBody>
       </p:sp>
@@ -486,34 +442,7 @@
           <a:bodyPr/>
           <a:lstStyle/>
           <a:p>
-            <a:r>
-              <a:t>SPEAKER NOTES (SLIDE 11):</a:t>
-            </a:r>
-          </a:p>
-          <a:p>
-            <a:r>
-              <a:t>Every honest data science assessment must articulate its limitations clearly:</a:t>
-            </a:r>
-          </a:p>
-          <a:p>
-            <a:r>
-              <a:t>First, selection bias: our application dataset contains only approved applicants. We have no data on rejected borrowers.</a:t>
-            </a:r>
-          </a:p>
-          <a:p>
-            <a:r>
-              <a:t>Second, missing portfolio data: 628 loans in Loan Performance have no application records. Because their default rate is 26% versus 54% for matched loans, this missingness is clearly non-random.</a:t>
-            </a:r>
-          </a:p>
-          <a:p>
-            <a:r>
-              <a:t>Third, proxy risk and omitted variables: while age was removed, correlated features like banking tenure or credit history depth can proxy for protected demographics. Moreover, we lack active debt obligation (DTI) data.</a:t>
-            </a:r>
-          </a:p>
-          <a:p>
-            <a:r>
-              <a:t>Because of these structural limitations, we strongly advise against deploying this model into automated production.</a:t>
-            </a:r>
+            <a:endParaRPr dirty="0"/>
           </a:p>
         </p:txBody>
       </p:sp>
@@ -581,39 +510,7 @@
           <a:bodyPr/>
           <a:lstStyle/>
           <a:p>
-            <a:r>
-              <a:t>SPEAKER NOTES (SLIDE 12):</a:t>
-            </a:r>
-          </a:p>
-          <a:p>
-            <a:r>
-              <a:t>To conclude, I recommend three strategic pillars for TapLend:</a:t>
-            </a:r>
-          </a:p>
-          <a:p>
-            <a:r>
-              <a:t>First, evidence-based underwriting inquiries: conduct controlled reviews of weekly repayment terms, evaluate bureau score floors against portfolio volume trade-offs, and validate repeat borrower loyalty programs across broader cohorts.</a:t>
-            </a:r>
-          </a:p>
-          <a:p>
-            <a:r>
-              <a:t>Second, fix data infrastructure: eliminate manual spreadsheet exports, recover the missing 628 application records, and begin logging all applicant rejections for future training.</a:t>
-            </a:r>
-          </a:p>
-          <a:p>
-            <a:r>
-              <a:t>Third, enrich applicant data: integrate verified debt-to-income and real-time bank transaction analytics through the Account Aggregator network, while conducting formal fair lending audits.</a:t>
-            </a:r>
-          </a:p>
-          <a:p>
-            <a:r>
-              <a:t>We explicitly advise against deploying this model into automated production at this stage.</a:t>
-            </a:r>
-          </a:p>
-          <a:p>
-            <a:r>
-              <a:t>Thank you for your time. I am now very happy to answer any questions.</a:t>
-            </a:r>
+            <a:endParaRPr dirty="0"/>
           </a:p>
         </p:txBody>
       </p:sp>
@@ -681,29 +578,7 @@
           <a:bodyPr/>
           <a:lstStyle/>
           <a:p>
-            <a:r>
-              <a:t>SPEAKER NOTES (SLIDE 2):</a:t>
-            </a:r>
-          </a:p>
-          <a:p>
-            <a:r>
-              <a:t>In digital consumer lending, underwriting is inherently an asymmetric economic problem. </a:t>
-            </a:r>
-          </a:p>
-          <a:p>
-            <a:r>
-              <a:t>If we approve a borrower who defaults, we lose unrecovered principal—illustrated here as roughly $500 based on average loan sizes. If we reject a creditworthy borrower, we lose the interest margin, illustrated as roughly $150.</a:t>
-            </a:r>
-          </a:p>
-          <a:p>
-            <a:r>
-              <a:t>I want to emphasize upfront that these dollar amounts are illustrative business assumptions, not numbers found in the raw assignment brief.</a:t>
-            </a:r>
-          </a:p>
-          <a:p>
-            <a:r>
-              <a:t>Because defaults are over three times as costly as missed loan opportunities, our threshold strategy cannot treat errors symmetrically. However, we must evaluate thresholds rigorously on holdout data to avoid overfitting.</a:t>
-            </a:r>
+            <a:endParaRPr dirty="0"/>
           </a:p>
         </p:txBody>
       </p:sp>
@@ -771,29 +646,7 @@
           <a:bodyPr/>
           <a:lstStyle/>
           <a:p>
-            <a:r>
-              <a:t>SPEAKER NOTES (SLIDE 3):</a:t>
-            </a:r>
-          </a:p>
-          <a:p>
-            <a:r>
-              <a:t>Here is an overview of the two tables provided in the assignment workbook:</a:t>
-            </a:r>
-          </a:p>
-          <a:p>
-            <a:r>
-              <a:t>Application Data has 647 rows and 31 columns. Every applicant in this dataset has status 'Approved'. It captures customer traits, requested loan terms, and five specialized credit bureau scores.</a:t>
-            </a:r>
-          </a:p>
-          <a:p>
-            <a:r>
-              <a:t>Loan Performance has 1,285 rows and two columns: idLoan and flgGood. 60% of loans are Good and 40% are Bad.</a:t>
-            </a:r>
-          </a:p>
-          <a:p>
-            <a:r>
-              <a:t>Immediately, an apparent discrepancy appears: there are 1,285 disbursed loans, but only 647 application records. Auditing this relationship was our first task.</a:t>
-            </a:r>
+            <a:endParaRPr dirty="0"/>
           </a:p>
         </p:txBody>
       </p:sp>
@@ -861,39 +714,7 @@
           <a:bodyPr/>
           <a:lstStyle/>
           <a:p>
-            <a:r>
-              <a:t>SPEAKER NOTES (SLIDE 4):</a:t>
-            </a:r>
-          </a:p>
-          <a:p>
-            <a:r>
-              <a:t>Let's address the data matching problem directly with verified facts:</a:t>
-            </a:r>
-          </a:p>
-          <a:p>
-            <a:r>
-              <a:t>1. In the baseline raw join, 656 loans matched. When we audited Row 567, we found an integer value 902431691. Excel stripped the leading zero; restoring it matches loan 0902431691-01, bringing total matched loans to 657 across 641 unique applicants.</a:t>
-            </a:r>
-          </a:p>
-          <a:p>
-            <a:r>
-              <a:t>2. 16 customers took repeat loans. All 16 had paid off their first loan successfully.</a:t>
-            </a:r>
-          </a:p>
-          <a:p>
-            <a:r>
-              <a:t>3. The remaining 628 loans in Loan Performance belong to customer prefixes that do not appear anywhere in Application Data. This is not inferred from row position—Application Data simply covers only 647 of the 1,269 total borrowers in that 6-month period.</a:t>
-            </a:r>
-          </a:p>
-          <a:p>
-            <a:r>
-              <a:t>4. Crucially, as shown on the chart, the matched cohort had a 54% default rate, while the unmatched cohort had only a 26% default rate.</a:t>
-            </a:r>
-          </a:p>
-          <a:p>
-            <a:r>
-              <a:t>Per strict data governance, we did not fabricate join keys. We preserved all 628 unmatched loans in unmatched_loans.csv, trained our models strictly on verified matched records, and documented this data pipeline gap.</a:t>
-            </a:r>
+            <a:endParaRPr dirty="0"/>
           </a:p>
         </p:txBody>
       </p:sp>
@@ -961,29 +782,7 @@
           <a:bodyPr/>
           <a:lstStyle/>
           <a:p>
-            <a:r>
-              <a:t>SPEAKER NOTES (SLIDE 5):</a:t>
-            </a:r>
-          </a:p>
-          <a:p>
-            <a:r>
-              <a:t>Looking at our exploratory data analysis:</a:t>
-            </a:r>
-          </a:p>
-          <a:p>
-            <a:r>
-              <a:t>First, all four specialized FICO scores—Retail, Telecom, Bank Card, and Money—demonstrate statistically significant separation between Good and Bad loans (p &lt; 0.001). Good borrowers averaged 15 to 20 points higher on bureau scores.</a:t>
-            </a:r>
-          </a:p>
-          <a:p>
-            <a:r>
-              <a:t>Second, a major surprise: applicant monthly income has no statistically significant correlation with loan default (p = 0.729). Higher self-reported gross income did not prevent defaults. This confirms that gross income without verified active debt obligations provides little risk signal.</a:t>
-            </a:r>
-          </a:p>
-          <a:p>
-            <a:r>
-              <a:t>Third, while applicant age showed an observational correlation with default, we deliberately removed age from predictive features due to fair lending compliance.</a:t>
-            </a:r>
+            <a:endParaRPr dirty="0"/>
           </a:p>
         </p:txBody>
       </p:sp>
@@ -1051,29 +850,7 @@
           <a:bodyPr/>
           <a:lstStyle/>
           <a:p>
-            <a:r>
-              <a:t>SPEAKER NOTES (SLIDE 6):</a:t>
-            </a:r>
-          </a:p>
-          <a:p>
-            <a:r>
-              <a:t>Examining repayment frequency reveals critical operational insights and methodological caveats:</a:t>
-            </a:r>
-          </a:p>
-          <a:p>
-            <a:r>
-              <a:t>As shown on the chart, applicants on weekly repayment schedules experienced an 81.5% default rate. However, we must be careful: this is an observational association in a small subgroup of only 27 loans, not established causation. Weekly terms do not necessarily cause default; rather, borrowers requiring weekly installments likely face severe cash-flow volatility.</a:t>
-            </a:r>
-          </a:p>
-          <a:p>
-            <a:r>
-              <a:t>Similarly, repeat borrowers defaulted at only 18.75% on loan -02 compared to 55% for first-time loans. But this reflects survivorship bias in a tiny sample of 16 borrowers who were selected precisely because they repaid their first loan.</a:t>
-            </a:r>
-          </a:p>
-          <a:p>
-            <a:r>
-              <a:t>Both findings warrant controlled operational review rather than definitive, unverified policy mandates.</a:t>
-            </a:r>
+            <a:endParaRPr dirty="0"/>
           </a:p>
         </p:txBody>
       </p:sp>
@@ -1141,34 +918,7 @@
           <a:bodyPr/>
           <a:lstStyle/>
           <a:p>
-            <a:r>
-              <a:t>SPEAKER NOTES (SLIDE 7):</a:t>
-            </a:r>
-          </a:p>
-          <a:p>
-            <a:r>
-              <a:t>Before building our models, strict feature engineering and fair lending hygiene were enforced.</a:t>
-            </a:r>
-          </a:p>
-          <a:p>
-            <a:r>
-              <a:t>First, applicant age was deliberately excluded from all predictive models to comply with ECOA fair lending regulations. </a:t>
-            </a:r>
-          </a:p>
-          <a:p>
-            <a:r>
-              <a:t>Importantly, we do NOT claim that removing age alone guarantees fairness. Other features—such as banking tenure, residential stability, or credit history depth—can act as proxy variables for age or socioeconomic status. Any real-world deployment requires formal Disparate Impact auditing.</a:t>
-            </a:r>
-          </a:p>
-          <a:p>
-            <a:r>
-              <a:t>Second, all post-decision underwriting fields—amount approved, duration approved, and payment approved—were stripped to prevent target leakage.</a:t>
-            </a:r>
-          </a:p>
-          <a:p>
-            <a:r>
-              <a:t>We then engineered clean financial ratios: payment-to-income, rent-to-income, total repayment cost ratio, and composite FICO.</a:t>
-            </a:r>
+            <a:endParaRPr dirty="0"/>
           </a:p>
         </p:txBody>
       </p:sp>
@@ -1236,29 +986,7 @@
           <a:bodyPr/>
           <a:lstStyle/>
           <a:p>
-            <a:r>
-              <a:t>SPEAKER NOTES (SLIDE 8):</a:t>
-            </a:r>
-          </a:p>
-          <a:p>
-            <a:r>
-              <a:t>To ensure complete technical rigor, we solved a critical validation problem: repeat borrower data leakage.</a:t>
-            </a:r>
-          </a:p>
-          <a:p>
-            <a:r>
-              <a:t>Because 16 customers took both a first and second loan, standard random splitting would place one loan from a customer in training and their second loan in testing. To eliminate this leak, we implemented GroupShuffleSplit on customer_key, ensuring that all loans for any given borrower were kept strictly on one side of the split.</a:t>
-            </a:r>
-          </a:p>
-          <a:p>
-            <a:r>
-              <a:t>Furthermore, all imputation and scaling parameters were learned exclusively from training folds through Scikit-Learn Pipelines.</a:t>
-            </a:r>
-          </a:p>
-          <a:p>
-            <a:r>
-              <a:t>We evaluated two complementary models: Logistic Regression for linear interpretability, and Random Forest to capture non-linear risk interactions.</a:t>
-            </a:r>
+            <a:endParaRPr dirty="0"/>
           </a:p>
         </p:txBody>
       </p:sp>
@@ -1326,34 +1054,7 @@
           <a:bodyPr/>
           <a:lstStyle/>
           <a:p>
-            <a:r>
-              <a:t>SPEAKER NOTES (SLIDE 9):</a:t>
-            </a:r>
-          </a:p>
-          <a:p>
-            <a:r>
-              <a:t>Here are our actual out-of-sample evaluation results on the holdout test set of 133 loans, trained without age.</a:t>
-            </a:r>
-          </a:p>
-          <a:p>
-            <a:r>
-              <a:t>Remember, our positive class is defined as a 'Bad Loan'—because detecting credit defaults is our core underwriting objective.</a:t>
-            </a:r>
-          </a:p>
-          <a:p>
-            <a:r>
-              <a:t>The Random Forest classifier demonstrated superior performance, achieving an ROC-AUC of 0.631 and a 73.2% recall on Bad loans. In practical terms, it successfully identified 52 out of the 71 defaulting borrowers in the holdout set.</a:t>
-            </a:r>
-          </a:p>
-          <a:p>
-            <a:r>
-              <a:t>Logistic Regression achieved 53.4% accuracy and 0.546 AUC.</a:t>
-            </a:r>
-          </a:p>
-          <a:p>
-            <a:r>
-              <a:t>Both models demonstrate meaningful signal, but overall discrimination remains moderate, primarily constrained by the sample size and the lack of verified debt obligation data.</a:t>
-            </a:r>
+            <a:endParaRPr dirty="0"/>
           </a:p>
         </p:txBody>
       </p:sp>

</xml_diff>